<commit_message>
Update presentation to 16:9 format and remove emojis
Changes:
- Changed slide dimensions from 10x7.5 to 13.333x7.5 (16:9 aspect ratio)
- Removed all emoji symbols and replaced with text markers
- Replaced emoji bullets with standard text markers (•, ▸, 【】)
- Updated Q&A format from emoji to Q:/A: format
- Maintained all content and structure while improving professionalism

This creates a more formal presentation suitable for academic settings.
</commit_message>
<xml_diff>
--- a/交換經驗分享會_蔡秀吉_百川學程.pptx
+++ b/交換經驗分享會_蔡秀吉_百川學程.pptx
@@ -24,7 +24,7 @@
     <p:sldId id="272" r:id="rId23"/>
     <p:sldId id="273" r:id="rId24"/>
   </p:sldIdLst>
-  <p:sldSz cx="9144000" cy="6858000" type="screen4x3"/>
+  <p:sldSz cx="12191695" cy="6858000" type="screen4x3"/>
   <p:notesSz cx="6858000" cy="9144000"/>
   <p:defaultTextStyle>
     <a:defPPr>
@@ -3347,196 +3347,196 @@
               </a:defRPr>
             </a:pPr>
             <a:r>
-              <a:t>⏰ 第一天</a:t>
-            </a:r>
-          </a:p>
-          <a:p>
-            <a:pPr>
-              <a:spcBef>
-                <a:spcPts val="1200"/>
-              </a:spcBef>
-              <a:defRPr sz="1800">
-                <a:solidFill>
-                  <a:srgbClr val="2C3E50"/>
-                </a:solidFill>
-              </a:defRPr>
-            </a:pPr>
-            <a:r>
-              <a:t>✓ 調時差（立刻調整作息）</a:t>
-            </a:r>
-          </a:p>
-          <a:p>
-            <a:pPr>
-              <a:spcBef>
-                <a:spcPts val="1200"/>
-              </a:spcBef>
-              <a:defRPr sz="1800">
-                <a:solidFill>
-                  <a:srgbClr val="2C3E50"/>
-                </a:solidFill>
-              </a:defRPr>
-            </a:pPr>
-            <a:r>
-              <a:t>✓ 確認住宿（檢查設施、記錄損壞）</a:t>
-            </a:r>
-          </a:p>
-          <a:p>
-            <a:pPr>
-              <a:spcBef>
-                <a:spcPts val="1200"/>
-              </a:spcBef>
-              <a:defRPr sz="1800">
-                <a:solidFill>
-                  <a:srgbClr val="2C3E50"/>
-                </a:solidFill>
-              </a:defRPr>
-            </a:pPr>
-            <a:r>
-              <a:t>✓ 購買網卡/申辦門號</a:t>
-            </a:r>
-          </a:p>
-          <a:p>
-            <a:pPr>
-              <a:spcBef>
-                <a:spcPts val="1200"/>
-              </a:spcBef>
-              <a:defRPr sz="1800">
-                <a:solidFill>
-                  <a:srgbClr val="2C3E50"/>
-                </a:solidFill>
-              </a:defRPr>
-            </a:pPr>
-            <a:r>
-              <a:t>✓ 買基本食物、日用品</a:t>
-            </a:r>
-          </a:p>
-          <a:p>
-            <a:pPr>
-              <a:spcBef>
-                <a:spcPts val="1200"/>
-              </a:spcBef>
-              <a:defRPr sz="1800">
-                <a:solidFill>
-                  <a:srgbClr val="2C3E50"/>
-                </a:solidFill>
-              </a:defRPr>
-            </a:pPr>
-          </a:p>
-          <a:p>
-            <a:pPr>
-              <a:spcBef>
-                <a:spcPts val="1200"/>
-              </a:spcBef>
-              <a:defRPr sz="1800">
-                <a:solidFill>
-                  <a:srgbClr val="2C3E50"/>
-                </a:solidFill>
-              </a:defRPr>
-            </a:pPr>
-            <a:r>
-              <a:t>⏰ 48小時內</a:t>
-            </a:r>
-          </a:p>
-          <a:p>
-            <a:pPr>
-              <a:spcBef>
-                <a:spcPts val="1200"/>
-              </a:spcBef>
-              <a:defRPr sz="1800">
-                <a:solidFill>
-                  <a:srgbClr val="2C3E50"/>
-                </a:solidFill>
-              </a:defRPr>
-            </a:pPr>
-            <a:r>
-              <a:t>✓ 開立當地銀行帳戶（需護照、入學證明、住址證明）</a:t>
-            </a:r>
-          </a:p>
-          <a:p>
-            <a:pPr>
-              <a:spcBef>
-                <a:spcPts val="1200"/>
-              </a:spcBef>
-              <a:defRPr sz="1800">
-                <a:solidFill>
-                  <a:srgbClr val="2C3E50"/>
-                </a:solidFill>
-              </a:defRPr>
-            </a:pPr>
-            <a:r>
-              <a:t>✓ 辦理學生證（各種優惠的關鍵）</a:t>
-            </a:r>
-          </a:p>
-          <a:p>
-            <a:pPr>
-              <a:spcBef>
-                <a:spcPts val="1200"/>
-              </a:spcBef>
-              <a:defRPr sz="1800">
-                <a:solidFill>
-                  <a:srgbClr val="2C3E50"/>
-                </a:solidFill>
-              </a:defRPr>
-            </a:pPr>
-            <a:r>
-              <a:t>✓ 購買交通月票</a:t>
-            </a:r>
-          </a:p>
-          <a:p>
-            <a:pPr>
-              <a:spcBef>
-                <a:spcPts val="1200"/>
-              </a:spcBef>
-              <a:defRPr sz="1800">
-                <a:solidFill>
-                  <a:srgbClr val="2C3E50"/>
-                </a:solidFill>
-              </a:defRPr>
-            </a:pPr>
-            <a:r>
-              <a:t>✓ 確認教室位置（提前踩點！門牌難找）</a:t>
-            </a:r>
-          </a:p>
-          <a:p>
-            <a:pPr>
-              <a:spcBef>
-                <a:spcPts val="1200"/>
-              </a:spcBef>
-              <a:defRPr sz="1800">
-                <a:solidFill>
-                  <a:srgbClr val="2C3E50"/>
-                </a:solidFill>
-              </a:defRPr>
-            </a:pPr>
-            <a:r>
-              <a:t>✓ 日本：到區公所辦轉入手續</a:t>
-            </a:r>
-          </a:p>
-          <a:p>
-            <a:pPr>
-              <a:spcBef>
-                <a:spcPts val="1200"/>
-              </a:spcBef>
-              <a:defRPr sz="1800">
-                <a:solidFill>
-                  <a:srgbClr val="2C3E50"/>
-                </a:solidFill>
-              </a:defRPr>
-            </a:pPr>
-          </a:p>
-          <a:p>
-            <a:pPr>
-              <a:spcBef>
-                <a:spcPts val="1200"/>
-              </a:spcBef>
-              <a:defRPr sz="1800">
-                <a:solidFill>
-                  <a:srgbClr val="2C3E50"/>
-                </a:solidFill>
-              </a:defRPr>
-            </a:pPr>
-            <a:r>
-              <a:t>💡 提醒：歐洲行政效率慢，辦事可能需3個工作日</a:t>
+              <a:t>【第一天】</a:t>
+            </a:r>
+          </a:p>
+          <a:p>
+            <a:pPr>
+              <a:spcBef>
+                <a:spcPts val="1200"/>
+              </a:spcBef>
+              <a:defRPr sz="1800">
+                <a:solidFill>
+                  <a:srgbClr val="2C3E50"/>
+                </a:solidFill>
+              </a:defRPr>
+            </a:pPr>
+            <a:r>
+              <a:t>• 調時差（立刻調整作息）</a:t>
+            </a:r>
+          </a:p>
+          <a:p>
+            <a:pPr>
+              <a:spcBef>
+                <a:spcPts val="1200"/>
+              </a:spcBef>
+              <a:defRPr sz="1800">
+                <a:solidFill>
+                  <a:srgbClr val="2C3E50"/>
+                </a:solidFill>
+              </a:defRPr>
+            </a:pPr>
+            <a:r>
+              <a:t>• 確認住宿（檢查設施、記錄損壞）</a:t>
+            </a:r>
+          </a:p>
+          <a:p>
+            <a:pPr>
+              <a:spcBef>
+                <a:spcPts val="1200"/>
+              </a:spcBef>
+              <a:defRPr sz="1800">
+                <a:solidFill>
+                  <a:srgbClr val="2C3E50"/>
+                </a:solidFill>
+              </a:defRPr>
+            </a:pPr>
+            <a:r>
+              <a:t>• 購買網卡/申辦門號</a:t>
+            </a:r>
+          </a:p>
+          <a:p>
+            <a:pPr>
+              <a:spcBef>
+                <a:spcPts val="1200"/>
+              </a:spcBef>
+              <a:defRPr sz="1800">
+                <a:solidFill>
+                  <a:srgbClr val="2C3E50"/>
+                </a:solidFill>
+              </a:defRPr>
+            </a:pPr>
+            <a:r>
+              <a:t>• 買基本食物、日用品</a:t>
+            </a:r>
+          </a:p>
+          <a:p>
+            <a:pPr>
+              <a:spcBef>
+                <a:spcPts val="1200"/>
+              </a:spcBef>
+              <a:defRPr sz="1800">
+                <a:solidFill>
+                  <a:srgbClr val="2C3E50"/>
+                </a:solidFill>
+              </a:defRPr>
+            </a:pPr>
+          </a:p>
+          <a:p>
+            <a:pPr>
+              <a:spcBef>
+                <a:spcPts val="1200"/>
+              </a:spcBef>
+              <a:defRPr sz="1800">
+                <a:solidFill>
+                  <a:srgbClr val="2C3E50"/>
+                </a:solidFill>
+              </a:defRPr>
+            </a:pPr>
+            <a:r>
+              <a:t>【48小時內】</a:t>
+            </a:r>
+          </a:p>
+          <a:p>
+            <a:pPr>
+              <a:spcBef>
+                <a:spcPts val="1200"/>
+              </a:spcBef>
+              <a:defRPr sz="1800">
+                <a:solidFill>
+                  <a:srgbClr val="2C3E50"/>
+                </a:solidFill>
+              </a:defRPr>
+            </a:pPr>
+            <a:r>
+              <a:t>• 開立當地銀行帳戶（需護照、入學證明、住址證明）</a:t>
+            </a:r>
+          </a:p>
+          <a:p>
+            <a:pPr>
+              <a:spcBef>
+                <a:spcPts val="1200"/>
+              </a:spcBef>
+              <a:defRPr sz="1800">
+                <a:solidFill>
+                  <a:srgbClr val="2C3E50"/>
+                </a:solidFill>
+              </a:defRPr>
+            </a:pPr>
+            <a:r>
+              <a:t>• 辦理學生證（各種優惠的關鍵）</a:t>
+            </a:r>
+          </a:p>
+          <a:p>
+            <a:pPr>
+              <a:spcBef>
+                <a:spcPts val="1200"/>
+              </a:spcBef>
+              <a:defRPr sz="1800">
+                <a:solidFill>
+                  <a:srgbClr val="2C3E50"/>
+                </a:solidFill>
+              </a:defRPr>
+            </a:pPr>
+            <a:r>
+              <a:t>• 購買交通月票</a:t>
+            </a:r>
+          </a:p>
+          <a:p>
+            <a:pPr>
+              <a:spcBef>
+                <a:spcPts val="1200"/>
+              </a:spcBef>
+              <a:defRPr sz="1800">
+                <a:solidFill>
+                  <a:srgbClr val="2C3E50"/>
+                </a:solidFill>
+              </a:defRPr>
+            </a:pPr>
+            <a:r>
+              <a:t>• 確認教室位置（提前踩點！門牌難找）</a:t>
+            </a:r>
+          </a:p>
+          <a:p>
+            <a:pPr>
+              <a:spcBef>
+                <a:spcPts val="1200"/>
+              </a:spcBef>
+              <a:defRPr sz="1800">
+                <a:solidFill>
+                  <a:srgbClr val="2C3E50"/>
+                </a:solidFill>
+              </a:defRPr>
+            </a:pPr>
+            <a:r>
+              <a:t>• 日本：到區公所辦轉入手續</a:t>
+            </a:r>
+          </a:p>
+          <a:p>
+            <a:pPr>
+              <a:spcBef>
+                <a:spcPts val="1200"/>
+              </a:spcBef>
+              <a:defRPr sz="1800">
+                <a:solidFill>
+                  <a:srgbClr val="2C3E50"/>
+                </a:solidFill>
+              </a:defRPr>
+            </a:pPr>
+          </a:p>
+          <a:p>
+            <a:pPr>
+              <a:spcBef>
+                <a:spcPts val="1200"/>
+              </a:spcBef>
+              <a:defRPr sz="1800">
+                <a:solidFill>
+                  <a:srgbClr val="2C3E50"/>
+                </a:solidFill>
+              </a:defRPr>
+            </a:pPr>
+            <a:r>
+              <a:t>【提醒】歐洲行政效率慢，辦事可能需3個工作日</a:t>
             </a:r>
           </a:p>
           <a:p>
@@ -3639,7 +3639,7 @@
               </a:defRPr>
             </a:pPr>
             <a:r>
-              <a:t>✅ 優勢</a:t>
+              <a:t>優勢面向</a:t>
             </a:r>
           </a:p>
         </p:txBody>
@@ -3677,7 +3677,7 @@
               </a:defRPr>
             </a:pPr>
             <a:r>
-              <a:t>😊 正面文化差異</a:t>
+              <a:t>【正面文化差異】</a:t>
             </a:r>
           </a:p>
           <a:p>
@@ -3779,7 +3779,7 @@
               </a:defRPr>
             </a:pPr>
             <a:r>
-              <a:t>🎓 學術差異</a:t>
+              <a:t>【學術差異】</a:t>
             </a:r>
           </a:p>
           <a:p>
@@ -3874,7 +3874,7 @@
               </a:defRPr>
             </a:pPr>
             <a:r>
-              <a:t>⚠️ 挑戰</a:t>
+              <a:t>挑戰面向</a:t>
             </a:r>
           </a:p>
         </p:txBody>
@@ -3912,7 +3912,7 @@
               </a:defRPr>
             </a:pPr>
             <a:r>
-              <a:t>😓 可能遇到的挑戰</a:t>
+              <a:t>【可能遇到的挑戰】</a:t>
             </a:r>
           </a:p>
           <a:p>
@@ -4029,7 +4029,7 @@
               </a:defRPr>
             </a:pPr>
             <a:r>
-              <a:t>💪 應對策略</a:t>
+              <a:t>【應對策略】</a:t>
             </a:r>
           </a:p>
           <a:p>
@@ -4223,7 +4223,7 @@
               </a:defRPr>
             </a:pPr>
             <a:r>
-              <a:t>🗣️ Speak Up - 為自己發聲</a:t>
+              <a:t>【Speak Up - 為自己發聲】</a:t>
             </a:r>
           </a:p>
           <a:p>
@@ -4295,7 +4295,7 @@
               </a:defRPr>
             </a:pPr>
             <a:r>
-              <a:t>🍜 破冰神器</a:t>
+              <a:t>【破冰神器】</a:t>
             </a:r>
           </a:p>
           <a:p>
@@ -4352,7 +4352,7 @@
               </a:defRPr>
             </a:pPr>
             <a:r>
-              <a:t>🧠 Work Smart, Not Just Work Hard</a:t>
+              <a:t>【Work Smart, Not Just Work Hard】</a:t>
             </a:r>
           </a:p>
           <a:p>
@@ -4424,7 +4424,7 @@
               </a:defRPr>
             </a:pPr>
             <a:r>
-              <a:t>🌍 文化差異理解</a:t>
+              <a:t>【文化差異理解】</a:t>
             </a:r>
           </a:p>
           <a:p>
@@ -4603,7 +4603,7 @@
               </a:defRPr>
             </a:pPr>
             <a:r>
-              <a:t>🎯 設定明確目標</a:t>
+              <a:t>【設定明確目標】</a:t>
             </a:r>
           </a:p>
           <a:p>
@@ -4675,7 +4675,7 @@
               </a:defRPr>
             </a:pPr>
             <a:r>
-              <a:t>🚀 Try New Things</a:t>
+              <a:t>【Try New Things】</a:t>
             </a:r>
           </a:p>
           <a:p>
@@ -4747,7 +4747,7 @@
               </a:defRPr>
             </a:pPr>
             <a:r>
-              <a:t>💎 找到研究/學習的熱情</a:t>
+              <a:t>【找到研究/學習的熱情】</a:t>
             </a:r>
           </a:p>
           <a:p>
@@ -4819,7 +4819,7 @@
               </a:defRPr>
             </a:pPr>
             <a:r>
-              <a:t>🏫 代表學校的責任</a:t>
+              <a:t>【代表學校的責任】</a:t>
             </a:r>
           </a:p>
           <a:p>
@@ -4983,34 +4983,34 @@
               </a:defRPr>
             </a:pPr>
             <a:r>
-              <a:t>📚 原則：讀書第一，旅遊第二</a:t>
-            </a:r>
-          </a:p>
-          <a:p>
-            <a:pPr>
-              <a:spcBef>
-                <a:spcPts val="1200"/>
-              </a:spcBef>
-              <a:defRPr sz="1800">
-                <a:solidFill>
-                  <a:srgbClr val="2C3E50"/>
-                </a:solidFill>
-              </a:defRPr>
-            </a:pPr>
-          </a:p>
-          <a:p>
-            <a:pPr>
-              <a:spcBef>
-                <a:spcPts val="1200"/>
-              </a:spcBef>
-              <a:defRPr sz="1800">
-                <a:solidFill>
-                  <a:srgbClr val="2C3E50"/>
-                </a:solidFill>
-              </a:defRPr>
-            </a:pPr>
-            <a:r>
-              <a:t>✅ 可行的平衡模式：</a:t>
+              <a:t>【原則】讀書第一，旅遊第二</a:t>
+            </a:r>
+          </a:p>
+          <a:p>
+            <a:pPr>
+              <a:spcBef>
+                <a:spcPts val="1200"/>
+              </a:spcBef>
+              <a:defRPr sz="1800">
+                <a:solidFill>
+                  <a:srgbClr val="2C3E50"/>
+                </a:solidFill>
+              </a:defRPr>
+            </a:pPr>
+          </a:p>
+          <a:p>
+            <a:pPr>
+              <a:spcBef>
+                <a:spcPts val="1200"/>
+              </a:spcBef>
+              <a:defRPr sz="1800">
+                <a:solidFill>
+                  <a:srgbClr val="2C3E50"/>
+                </a:solidFill>
+              </a:defRPr>
+            </a:pPr>
+            <a:r>
+              <a:t>可行的平衡模式：</a:t>
             </a:r>
           </a:p>
           <a:p>
@@ -5097,79 +5097,79 @@
               </a:defRPr>
             </a:pPr>
             <a:r>
-              <a:t>⚠️ 避免的陷阱：</a:t>
-            </a:r>
-          </a:p>
-          <a:p>
-            <a:pPr>
-              <a:spcBef>
-                <a:spcPts val="1200"/>
-              </a:spcBef>
-              <a:defRPr sz="1800">
-                <a:solidFill>
-                  <a:srgbClr val="2C3E50"/>
-                </a:solidFill>
-              </a:defRPr>
-            </a:pPr>
-            <a:r>
-              <a:t>✗ 完全不旅遊（浪費地理優勢）</a:t>
-            </a:r>
-          </a:p>
-          <a:p>
-            <a:pPr>
-              <a:spcBef>
-                <a:spcPts val="1200"/>
-              </a:spcBef>
-              <a:defRPr sz="1800">
-                <a:solidFill>
-                  <a:srgbClr val="2C3E50"/>
-                </a:solidFill>
-              </a:defRPr>
-            </a:pPr>
-            <a:r>
-              <a:t>✗ 過度旅遊（學業掛掉）</a:t>
-            </a:r>
-          </a:p>
-          <a:p>
-            <a:pPr>
-              <a:spcBef>
-                <a:spcPts val="1200"/>
-              </a:spcBef>
-              <a:defRPr sz="1800">
-                <a:solidFill>
-                  <a:srgbClr val="2C3E50"/>
-                </a:solidFill>
-              </a:defRPr>
-            </a:pPr>
-            <a:r>
-              <a:t>✗ 臨時起意（機票住宿貴、時間浪費）</a:t>
-            </a:r>
-          </a:p>
-          <a:p>
-            <a:pPr>
-              <a:spcBef>
-                <a:spcPts val="1200"/>
-              </a:spcBef>
-              <a:defRPr sz="1800">
-                <a:solidFill>
-                  <a:srgbClr val="2C3E50"/>
-                </a:solidFill>
-              </a:defRPr>
-            </a:pPr>
-          </a:p>
-          <a:p>
-            <a:pPr>
-              <a:spcBef>
-                <a:spcPts val="1200"/>
-              </a:spcBef>
-              <a:defRPr sz="1800">
-                <a:solidFill>
-                  <a:srgbClr val="2C3E50"/>
-                </a:solidFill>
-              </a:defRPr>
-            </a:pPr>
-            <a:r>
-              <a:t>💡 時間管理技巧：</a:t>
+              <a:t>避免的陷阱：</a:t>
+            </a:r>
+          </a:p>
+          <a:p>
+            <a:pPr>
+              <a:spcBef>
+                <a:spcPts val="1200"/>
+              </a:spcBef>
+              <a:defRPr sz="1800">
+                <a:solidFill>
+                  <a:srgbClr val="2C3E50"/>
+                </a:solidFill>
+              </a:defRPr>
+            </a:pPr>
+            <a:r>
+              <a:t>• 完全不旅遊（浪費地理優勢）</a:t>
+            </a:r>
+          </a:p>
+          <a:p>
+            <a:pPr>
+              <a:spcBef>
+                <a:spcPts val="1200"/>
+              </a:spcBef>
+              <a:defRPr sz="1800">
+                <a:solidFill>
+                  <a:srgbClr val="2C3E50"/>
+                </a:solidFill>
+              </a:defRPr>
+            </a:pPr>
+            <a:r>
+              <a:t>• 過度旅遊（學業掛掉）</a:t>
+            </a:r>
+          </a:p>
+          <a:p>
+            <a:pPr>
+              <a:spcBef>
+                <a:spcPts val="1200"/>
+              </a:spcBef>
+              <a:defRPr sz="1800">
+                <a:solidFill>
+                  <a:srgbClr val="2C3E50"/>
+                </a:solidFill>
+              </a:defRPr>
+            </a:pPr>
+            <a:r>
+              <a:t>• 臨時起意（機票住宿貴、時間浪費）</a:t>
+            </a:r>
+          </a:p>
+          <a:p>
+            <a:pPr>
+              <a:spcBef>
+                <a:spcPts val="1200"/>
+              </a:spcBef>
+              <a:defRPr sz="1800">
+                <a:solidFill>
+                  <a:srgbClr val="2C3E50"/>
+                </a:solidFill>
+              </a:defRPr>
+            </a:pPr>
+          </a:p>
+          <a:p>
+            <a:pPr>
+              <a:spcBef>
+                <a:spcPts val="1200"/>
+              </a:spcBef>
+              <a:defRPr sz="1800">
+                <a:solidFill>
+                  <a:srgbClr val="2C3E50"/>
+                </a:solidFill>
+              </a:defRPr>
+            </a:pPr>
+            <a:r>
+              <a:t>時間管理技巧：</a:t>
             </a:r>
           </a:p>
           <a:p>
@@ -5348,79 +5348,79 @@
               </a:defRPr>
             </a:pPr>
             <a:r>
-              <a:t>🎓 百川人的獨特優勢：</a:t>
-            </a:r>
-          </a:p>
-          <a:p>
-            <a:pPr>
-              <a:spcBef>
-                <a:spcPts val="1200"/>
-              </a:spcBef>
-              <a:defRPr sz="1800">
-                <a:solidFill>
-                  <a:srgbClr val="2C3E50"/>
-                </a:solidFill>
-              </a:defRPr>
-            </a:pPr>
-            <a:r>
-              <a:t>✓ 跨領域背景 = 國際競爭力</a:t>
-            </a:r>
-          </a:p>
-          <a:p>
-            <a:pPr>
-              <a:spcBef>
-                <a:spcPts val="1200"/>
-              </a:spcBef>
-              <a:defRPr sz="1800">
-                <a:solidFill>
-                  <a:srgbClr val="2C3E50"/>
-                </a:solidFill>
-              </a:defRPr>
-            </a:pPr>
-            <a:r>
-              <a:t>✓ 能整合不同領域的視角</a:t>
-            </a:r>
-          </a:p>
-          <a:p>
-            <a:pPr>
-              <a:spcBef>
-                <a:spcPts val="1200"/>
-              </a:spcBef>
-              <a:defRPr sz="1800">
-                <a:solidFill>
-                  <a:srgbClr val="2C3E50"/>
-                </a:solidFill>
-              </a:defRPr>
-            </a:pPr>
-            <a:r>
-              <a:t>✓ 適合申請需要創新思維的計畫</a:t>
-            </a:r>
-          </a:p>
-          <a:p>
-            <a:pPr>
-              <a:spcBef>
-                <a:spcPts val="1200"/>
-              </a:spcBef>
-              <a:defRPr sz="1800">
-                <a:solidFill>
-                  <a:srgbClr val="2C3E50"/>
-                </a:solidFill>
-              </a:defRPr>
-            </a:pPr>
-          </a:p>
-          <a:p>
-            <a:pPr>
-              <a:spcBef>
-                <a:spcPts val="1200"/>
-              </a:spcBef>
-              <a:defRPr sz="1800">
-                <a:solidFill>
-                  <a:srgbClr val="2C3E50"/>
-                </a:solidFill>
-              </a:defRPr>
-            </a:pPr>
-            <a:r>
-              <a:t>🛤️ 開闢外軌途徑：</a:t>
+              <a:t>【百川人的獨特優勢】</a:t>
+            </a:r>
+          </a:p>
+          <a:p>
+            <a:pPr>
+              <a:spcBef>
+                <a:spcPts val="1200"/>
+              </a:spcBef>
+              <a:defRPr sz="1800">
+                <a:solidFill>
+                  <a:srgbClr val="2C3E50"/>
+                </a:solidFill>
+              </a:defRPr>
+            </a:pPr>
+            <a:r>
+              <a:t>• 跨領域背景 = 國際競爭力</a:t>
+            </a:r>
+          </a:p>
+          <a:p>
+            <a:pPr>
+              <a:spcBef>
+                <a:spcPts val="1200"/>
+              </a:spcBef>
+              <a:defRPr sz="1800">
+                <a:solidFill>
+                  <a:srgbClr val="2C3E50"/>
+                </a:solidFill>
+              </a:defRPr>
+            </a:pPr>
+            <a:r>
+              <a:t>• 能整合不同領域的視角</a:t>
+            </a:r>
+          </a:p>
+          <a:p>
+            <a:pPr>
+              <a:spcBef>
+                <a:spcPts val="1200"/>
+              </a:spcBef>
+              <a:defRPr sz="1800">
+                <a:solidFill>
+                  <a:srgbClr val="2C3E50"/>
+                </a:solidFill>
+              </a:defRPr>
+            </a:pPr>
+            <a:r>
+              <a:t>• 適合申請需要創新思維的計畫</a:t>
+            </a:r>
+          </a:p>
+          <a:p>
+            <a:pPr>
+              <a:spcBef>
+                <a:spcPts val="1200"/>
+              </a:spcBef>
+              <a:defRPr sz="1800">
+                <a:solidFill>
+                  <a:srgbClr val="2C3E50"/>
+                </a:solidFill>
+              </a:defRPr>
+            </a:pPr>
+          </a:p>
+          <a:p>
+            <a:pPr>
+              <a:spcBef>
+                <a:spcPts val="1200"/>
+              </a:spcBef>
+              <a:defRPr sz="1800">
+                <a:solidFill>
+                  <a:srgbClr val="2C3E50"/>
+                </a:solidFill>
+              </a:defRPr>
+            </a:pPr>
+            <a:r>
+              <a:t>【開闢外軌途徑】</a:t>
             </a:r>
           </a:p>
           <a:p>
@@ -5507,7 +5507,7 @@
               </a:defRPr>
             </a:pPr>
             <a:r>
-              <a:t>📝 大二/大三就要開始準備：</a:t>
+              <a:t>【大二/大三就要開始準備】</a:t>
             </a:r>
           </a:p>
           <a:p>
@@ -5594,7 +5594,7 @@
               </a:defRPr>
             </a:pPr>
             <a:r>
-              <a:t>💼 大五/畢業生也能申請（透過學校推薦）</a:t>
+              <a:t>【備註】大五/畢業生也能申請（透過學校推薦）</a:t>
             </a:r>
           </a:p>
         </p:txBody>
@@ -5728,196 +5728,196 @@
               </a:defRPr>
             </a:pPr>
             <a:r>
-              <a:t>⏰ 提早規劃（12-18個月前開始）</a:t>
-            </a:r>
-          </a:p>
-          <a:p>
-            <a:pPr>
-              <a:spcBef>
-                <a:spcPts val="1200"/>
-              </a:spcBef>
-              <a:defRPr sz="1800">
-                <a:solidFill>
-                  <a:srgbClr val="2C3E50"/>
-                </a:solidFill>
-              </a:defRPr>
-            </a:pPr>
-          </a:p>
-          <a:p>
-            <a:pPr>
-              <a:spcBef>
-                <a:spcPts val="1200"/>
-              </a:spcBef>
-              <a:defRPr sz="1800">
-                <a:solidFill>
-                  <a:srgbClr val="2C3E50"/>
-                </a:solidFill>
-              </a:defRPr>
-            </a:pPr>
-            <a:r>
-              <a:t>🎯 釐清目的（玩樂 vs 進修 vs 平衡）</a:t>
-            </a:r>
-          </a:p>
-          <a:p>
-            <a:pPr>
-              <a:spcBef>
-                <a:spcPts val="1200"/>
-              </a:spcBef>
-              <a:defRPr sz="1800">
-                <a:solidFill>
-                  <a:srgbClr val="2C3E50"/>
-                </a:solidFill>
-              </a:defRPr>
-            </a:pPr>
-          </a:p>
-          <a:p>
-            <a:pPr>
-              <a:spcBef>
-                <a:spcPts val="1200"/>
-              </a:spcBef>
-              <a:defRPr sz="1800">
-                <a:solidFill>
-                  <a:srgbClr val="2C3E50"/>
-                </a:solidFill>
-              </a:defRPr>
-            </a:pPr>
-            <a:r>
-              <a:t>📚 三大支柱（英文、GPA、動機）</a:t>
-            </a:r>
-          </a:p>
-          <a:p>
-            <a:pPr>
-              <a:spcBef>
-                <a:spcPts val="1200"/>
-              </a:spcBef>
-              <a:defRPr sz="1800">
-                <a:solidFill>
-                  <a:srgbClr val="2C3E50"/>
-                </a:solidFill>
-              </a:defRPr>
-            </a:pPr>
-          </a:p>
-          <a:p>
-            <a:pPr>
-              <a:spcBef>
-                <a:spcPts val="1200"/>
-              </a:spcBef>
-              <a:defRPr sz="1800">
-                <a:solidFill>
-                  <a:srgbClr val="2C3E50"/>
-                </a:solidFill>
-              </a:defRPr>
-            </a:pPr>
-            <a:r>
-              <a:t>💰 善用獎學金（學海計畫、教育部獎學金）</a:t>
-            </a:r>
-          </a:p>
-          <a:p>
-            <a:pPr>
-              <a:spcBef>
-                <a:spcPts val="1200"/>
-              </a:spcBef>
-              <a:defRPr sz="1800">
-                <a:solidFill>
-                  <a:srgbClr val="2C3E50"/>
-                </a:solidFill>
-              </a:defRPr>
-            </a:pPr>
-          </a:p>
-          <a:p>
-            <a:pPr>
-              <a:spcBef>
-                <a:spcPts val="1200"/>
-              </a:spcBef>
-              <a:defRPr sz="1800">
-                <a:solidFill>
-                  <a:srgbClr val="2C3E50"/>
-                </a:solidFill>
-              </a:defRPr>
-            </a:pPr>
-            <a:r>
-              <a:t>🧳 行前準備（簽證、保險、網卡、2張信用卡）</a:t>
-            </a:r>
-          </a:p>
-          <a:p>
-            <a:pPr>
-              <a:spcBef>
-                <a:spcPts val="1200"/>
-              </a:spcBef>
-              <a:defRPr sz="1800">
-                <a:solidFill>
-                  <a:srgbClr val="2C3E50"/>
-                </a:solidFill>
-              </a:defRPr>
-            </a:pPr>
-          </a:p>
-          <a:p>
-            <a:pPr>
-              <a:spcBef>
-                <a:spcPts val="1200"/>
-              </a:spcBef>
-              <a:defRPr sz="1800">
-                <a:solidFill>
-                  <a:srgbClr val="2C3E50"/>
-                </a:solidFill>
-              </a:defRPr>
-            </a:pPr>
-            <a:r>
-              <a:t>🗣️ Speak Up &amp; Work Smart</a:t>
-            </a:r>
-          </a:p>
-          <a:p>
-            <a:pPr>
-              <a:spcBef>
-                <a:spcPts val="1200"/>
-              </a:spcBef>
-              <a:defRPr sz="1800">
-                <a:solidFill>
-                  <a:srgbClr val="2C3E50"/>
-                </a:solidFill>
-              </a:defRPr>
-            </a:pPr>
-          </a:p>
-          <a:p>
-            <a:pPr>
-              <a:spcBef>
-                <a:spcPts val="1200"/>
-              </a:spcBef>
-              <a:defRPr sz="1800">
-                <a:solidFill>
-                  <a:srgbClr val="2C3E50"/>
-                </a:solidFill>
-              </a:defRPr>
-            </a:pPr>
-            <a:r>
-              <a:t>🌱 Try New Things &amp; 跳脫舒適圈</a:t>
-            </a:r>
-          </a:p>
-          <a:p>
-            <a:pPr>
-              <a:spcBef>
-                <a:spcPts val="1200"/>
-              </a:spcBef>
-              <a:defRPr sz="1800">
-                <a:solidFill>
-                  <a:srgbClr val="2C3E50"/>
-                </a:solidFill>
-              </a:defRPr>
-            </a:pPr>
-          </a:p>
-          <a:p>
-            <a:pPr>
-              <a:spcBef>
-                <a:spcPts val="1200"/>
-              </a:spcBef>
-              <a:defRPr sz="1800">
-                <a:solidFill>
-                  <a:srgbClr val="2C3E50"/>
-                </a:solidFill>
-              </a:defRPr>
-            </a:pPr>
-            <a:r>
-              <a:t>🏆 代表學校，為自己創造機會</a:t>
+              <a:t>▸ 提早規劃（12-18個月前開始）</a:t>
+            </a:r>
+          </a:p>
+          <a:p>
+            <a:pPr>
+              <a:spcBef>
+                <a:spcPts val="1200"/>
+              </a:spcBef>
+              <a:defRPr sz="1800">
+                <a:solidFill>
+                  <a:srgbClr val="2C3E50"/>
+                </a:solidFill>
+              </a:defRPr>
+            </a:pPr>
+          </a:p>
+          <a:p>
+            <a:pPr>
+              <a:spcBef>
+                <a:spcPts val="1200"/>
+              </a:spcBef>
+              <a:defRPr sz="1800">
+                <a:solidFill>
+                  <a:srgbClr val="2C3E50"/>
+                </a:solidFill>
+              </a:defRPr>
+            </a:pPr>
+            <a:r>
+              <a:t>▸ 釐清目的（玩樂 vs 進修 vs 平衡）</a:t>
+            </a:r>
+          </a:p>
+          <a:p>
+            <a:pPr>
+              <a:spcBef>
+                <a:spcPts val="1200"/>
+              </a:spcBef>
+              <a:defRPr sz="1800">
+                <a:solidFill>
+                  <a:srgbClr val="2C3E50"/>
+                </a:solidFill>
+              </a:defRPr>
+            </a:pPr>
+          </a:p>
+          <a:p>
+            <a:pPr>
+              <a:spcBef>
+                <a:spcPts val="1200"/>
+              </a:spcBef>
+              <a:defRPr sz="1800">
+                <a:solidFill>
+                  <a:srgbClr val="2C3E50"/>
+                </a:solidFill>
+              </a:defRPr>
+            </a:pPr>
+            <a:r>
+              <a:t>▸ 三大支柱（英文、GPA、動機）</a:t>
+            </a:r>
+          </a:p>
+          <a:p>
+            <a:pPr>
+              <a:spcBef>
+                <a:spcPts val="1200"/>
+              </a:spcBef>
+              <a:defRPr sz="1800">
+                <a:solidFill>
+                  <a:srgbClr val="2C3E50"/>
+                </a:solidFill>
+              </a:defRPr>
+            </a:pPr>
+          </a:p>
+          <a:p>
+            <a:pPr>
+              <a:spcBef>
+                <a:spcPts val="1200"/>
+              </a:spcBef>
+              <a:defRPr sz="1800">
+                <a:solidFill>
+                  <a:srgbClr val="2C3E50"/>
+                </a:solidFill>
+              </a:defRPr>
+            </a:pPr>
+            <a:r>
+              <a:t>▸ 善用獎學金（學海計畫、教育部獎學金）</a:t>
+            </a:r>
+          </a:p>
+          <a:p>
+            <a:pPr>
+              <a:spcBef>
+                <a:spcPts val="1200"/>
+              </a:spcBef>
+              <a:defRPr sz="1800">
+                <a:solidFill>
+                  <a:srgbClr val="2C3E50"/>
+                </a:solidFill>
+              </a:defRPr>
+            </a:pPr>
+          </a:p>
+          <a:p>
+            <a:pPr>
+              <a:spcBef>
+                <a:spcPts val="1200"/>
+              </a:spcBef>
+              <a:defRPr sz="1800">
+                <a:solidFill>
+                  <a:srgbClr val="2C3E50"/>
+                </a:solidFill>
+              </a:defRPr>
+            </a:pPr>
+            <a:r>
+              <a:t>▸ 行前準備（簽證、保險、網卡、2張信用卡）</a:t>
+            </a:r>
+          </a:p>
+          <a:p>
+            <a:pPr>
+              <a:spcBef>
+                <a:spcPts val="1200"/>
+              </a:spcBef>
+              <a:defRPr sz="1800">
+                <a:solidFill>
+                  <a:srgbClr val="2C3E50"/>
+                </a:solidFill>
+              </a:defRPr>
+            </a:pPr>
+          </a:p>
+          <a:p>
+            <a:pPr>
+              <a:spcBef>
+                <a:spcPts val="1200"/>
+              </a:spcBef>
+              <a:defRPr sz="1800">
+                <a:solidFill>
+                  <a:srgbClr val="2C3E50"/>
+                </a:solidFill>
+              </a:defRPr>
+            </a:pPr>
+            <a:r>
+              <a:t>▸ Speak Up &amp; Work Smart</a:t>
+            </a:r>
+          </a:p>
+          <a:p>
+            <a:pPr>
+              <a:spcBef>
+                <a:spcPts val="1200"/>
+              </a:spcBef>
+              <a:defRPr sz="1800">
+                <a:solidFill>
+                  <a:srgbClr val="2C3E50"/>
+                </a:solidFill>
+              </a:defRPr>
+            </a:pPr>
+          </a:p>
+          <a:p>
+            <a:pPr>
+              <a:spcBef>
+                <a:spcPts val="1200"/>
+              </a:spcBef>
+              <a:defRPr sz="1800">
+                <a:solidFill>
+                  <a:srgbClr val="2C3E50"/>
+                </a:solidFill>
+              </a:defRPr>
+            </a:pPr>
+            <a:r>
+              <a:t>▸ Try New Things &amp; 跳脫舒適圈</a:t>
+            </a:r>
+          </a:p>
+          <a:p>
+            <a:pPr>
+              <a:spcBef>
+                <a:spcPts val="1200"/>
+              </a:spcBef>
+              <a:defRPr sz="1800">
+                <a:solidFill>
+                  <a:srgbClr val="2C3E50"/>
+                </a:solidFill>
+              </a:defRPr>
+            </a:pPr>
+          </a:p>
+          <a:p>
+            <a:pPr>
+              <a:spcBef>
+                <a:spcPts val="1200"/>
+              </a:spcBef>
+              <a:defRPr sz="1800">
+                <a:solidFill>
+                  <a:srgbClr val="2C3E50"/>
+                </a:solidFill>
+              </a:defRPr>
+            </a:pPr>
+            <a:r>
+              <a:t>▸ 代表學校，為自己創造機會</a:t>
             </a:r>
           </a:p>
         </p:txBody>
@@ -6051,190 +6051,190 @@
               </a:defRPr>
             </a:pPr>
             <a:r>
-              <a:t>❓ GPA要多少才能申請？</a:t>
-            </a:r>
-          </a:p>
-          <a:p>
-            <a:pPr>
-              <a:spcBef>
-                <a:spcPts val="1200"/>
-              </a:spcBef>
-              <a:defRPr sz="1800">
-                <a:solidFill>
-                  <a:srgbClr val="2C3E50"/>
-                </a:solidFill>
-              </a:defRPr>
-            </a:pPr>
-            <a:r>
-              <a:t>→ 沒有絕對標準，但越高越好。學海計畫各校標準不同。</a:t>
-            </a:r>
-          </a:p>
-          <a:p>
-            <a:pPr>
-              <a:spcBef>
-                <a:spcPts val="1200"/>
-              </a:spcBef>
-              <a:defRPr sz="1800">
-                <a:solidFill>
-                  <a:srgbClr val="2C3E50"/>
-                </a:solidFill>
-              </a:defRPr>
-            </a:pPr>
-          </a:p>
-          <a:p>
-            <a:pPr>
-              <a:spcBef>
-                <a:spcPts val="1200"/>
-              </a:spcBef>
-              <a:defRPr sz="1800">
-                <a:solidFill>
-                  <a:srgbClr val="2C3E50"/>
-                </a:solidFill>
-              </a:defRPr>
-            </a:pPr>
-            <a:r>
-              <a:t>❓ 英文要考到幾分？</a:t>
-            </a:r>
-          </a:p>
-          <a:p>
-            <a:pPr>
-              <a:spcBef>
-                <a:spcPts val="1200"/>
-              </a:spcBef>
-              <a:defRPr sz="1800">
-                <a:solidFill>
-                  <a:srgbClr val="2C3E50"/>
-                </a:solidFill>
-              </a:defRPr>
-            </a:pPr>
-            <a:r>
-              <a:t>→ 多數學校：托福80+ / 雅思6.0+ / 在校英文80+</a:t>
-            </a:r>
-          </a:p>
-          <a:p>
-            <a:pPr>
-              <a:spcBef>
-                <a:spcPts val="1200"/>
-              </a:spcBef>
-              <a:defRPr sz="1800">
-                <a:solidFill>
-                  <a:srgbClr val="2C3E50"/>
-                </a:solidFill>
-              </a:defRPr>
-            </a:pPr>
-          </a:p>
-          <a:p>
-            <a:pPr>
-              <a:spcBef>
-                <a:spcPts val="1200"/>
-              </a:spcBef>
-              <a:defRPr sz="1800">
-                <a:solidFill>
-                  <a:srgbClr val="2C3E50"/>
-                </a:solidFill>
-              </a:defRPr>
-            </a:pPr>
-            <a:r>
-              <a:t>❓ 沒有姊妹校可以交換嗎？</a:t>
-            </a:r>
-          </a:p>
-          <a:p>
-            <a:pPr>
-              <a:spcBef>
-                <a:spcPts val="1200"/>
-              </a:spcBef>
-              <a:defRPr sz="1800">
-                <a:solidFill>
-                  <a:srgbClr val="2C3E50"/>
-                </a:solidFill>
-              </a:defRPr>
-            </a:pPr>
-            <a:r>
-              <a:t>→ 可以！透過教育部獎學金，不限姊妹校。</a:t>
-            </a:r>
-          </a:p>
-          <a:p>
-            <a:pPr>
-              <a:spcBef>
-                <a:spcPts val="1200"/>
-              </a:spcBef>
-              <a:defRPr sz="1800">
-                <a:solidFill>
-                  <a:srgbClr val="2C3E50"/>
-                </a:solidFill>
-              </a:defRPr>
-            </a:pPr>
-          </a:p>
-          <a:p>
-            <a:pPr>
-              <a:spcBef>
-                <a:spcPts val="1200"/>
-              </a:spcBef>
-              <a:defRPr sz="1800">
-                <a:solidFill>
-                  <a:srgbClr val="2C3E50"/>
-                </a:solidFill>
-              </a:defRPr>
-            </a:pPr>
-            <a:r>
-              <a:t>❓ 交換要花多少錢？</a:t>
-            </a:r>
-          </a:p>
-          <a:p>
-            <a:pPr>
-              <a:spcBef>
-                <a:spcPts val="1200"/>
-              </a:spcBef>
-              <a:defRPr sz="1800">
-                <a:solidFill>
-                  <a:srgbClr val="2C3E50"/>
-                </a:solidFill>
-              </a:defRPr>
-            </a:pPr>
-            <a:r>
-              <a:t>→ 視國家而定。學海計畫補助5-30萬，力學優秀生可全額。</a:t>
-            </a:r>
-          </a:p>
-          <a:p>
-            <a:pPr>
-              <a:spcBef>
-                <a:spcPts val="1200"/>
-              </a:spcBef>
-              <a:defRPr sz="1800">
-                <a:solidFill>
-                  <a:srgbClr val="2C3E50"/>
-                </a:solidFill>
-              </a:defRPr>
-            </a:pPr>
-          </a:p>
-          <a:p>
-            <a:pPr>
-              <a:spcBef>
-                <a:spcPts val="1200"/>
-              </a:spcBef>
-              <a:defRPr sz="1800">
-                <a:solidFill>
-                  <a:srgbClr val="2C3E50"/>
-                </a:solidFill>
-              </a:defRPr>
-            </a:pPr>
-            <a:r>
-              <a:t>❓ 現在開始準備來得及嗎？</a:t>
-            </a:r>
-          </a:p>
-          <a:p>
-            <a:pPr>
-              <a:spcBef>
-                <a:spcPts val="1200"/>
-              </a:spcBef>
-              <a:defRPr sz="1800">
-                <a:solidFill>
-                  <a:srgbClr val="2C3E50"/>
-                </a:solidFill>
-              </a:defRPr>
-            </a:pPr>
-            <a:r>
-              <a:t>→ 看你想何時出發。至少需要12個月準備時間。</a:t>
+              <a:t>Q: GPA要多少才能申請？</a:t>
+            </a:r>
+          </a:p>
+          <a:p>
+            <a:pPr>
+              <a:spcBef>
+                <a:spcPts val="1200"/>
+              </a:spcBef>
+              <a:defRPr sz="1800">
+                <a:solidFill>
+                  <a:srgbClr val="2C3E50"/>
+                </a:solidFill>
+              </a:defRPr>
+            </a:pPr>
+            <a:r>
+              <a:t>A: 沒有絕對標準，但越高越好。學海計畫各校標準不同。</a:t>
+            </a:r>
+          </a:p>
+          <a:p>
+            <a:pPr>
+              <a:spcBef>
+                <a:spcPts val="1200"/>
+              </a:spcBef>
+              <a:defRPr sz="1800">
+                <a:solidFill>
+                  <a:srgbClr val="2C3E50"/>
+                </a:solidFill>
+              </a:defRPr>
+            </a:pPr>
+          </a:p>
+          <a:p>
+            <a:pPr>
+              <a:spcBef>
+                <a:spcPts val="1200"/>
+              </a:spcBef>
+              <a:defRPr sz="1800">
+                <a:solidFill>
+                  <a:srgbClr val="2C3E50"/>
+                </a:solidFill>
+              </a:defRPr>
+            </a:pPr>
+            <a:r>
+              <a:t>Q: 英文要考到幾分？</a:t>
+            </a:r>
+          </a:p>
+          <a:p>
+            <a:pPr>
+              <a:spcBef>
+                <a:spcPts val="1200"/>
+              </a:spcBef>
+              <a:defRPr sz="1800">
+                <a:solidFill>
+                  <a:srgbClr val="2C3E50"/>
+                </a:solidFill>
+              </a:defRPr>
+            </a:pPr>
+            <a:r>
+              <a:t>A: 多數學校：托福80+ / 雅思6.0+ / 在校英文80+</a:t>
+            </a:r>
+          </a:p>
+          <a:p>
+            <a:pPr>
+              <a:spcBef>
+                <a:spcPts val="1200"/>
+              </a:spcBef>
+              <a:defRPr sz="1800">
+                <a:solidFill>
+                  <a:srgbClr val="2C3E50"/>
+                </a:solidFill>
+              </a:defRPr>
+            </a:pPr>
+          </a:p>
+          <a:p>
+            <a:pPr>
+              <a:spcBef>
+                <a:spcPts val="1200"/>
+              </a:spcBef>
+              <a:defRPr sz="1800">
+                <a:solidFill>
+                  <a:srgbClr val="2C3E50"/>
+                </a:solidFill>
+              </a:defRPr>
+            </a:pPr>
+            <a:r>
+              <a:t>Q: 沒有姊妹校可以交換嗎？</a:t>
+            </a:r>
+          </a:p>
+          <a:p>
+            <a:pPr>
+              <a:spcBef>
+                <a:spcPts val="1200"/>
+              </a:spcBef>
+              <a:defRPr sz="1800">
+                <a:solidFill>
+                  <a:srgbClr val="2C3E50"/>
+                </a:solidFill>
+              </a:defRPr>
+            </a:pPr>
+            <a:r>
+              <a:t>A: 可以！透過教育部獎學金，不限姊妹校。</a:t>
+            </a:r>
+          </a:p>
+          <a:p>
+            <a:pPr>
+              <a:spcBef>
+                <a:spcPts val="1200"/>
+              </a:spcBef>
+              <a:defRPr sz="1800">
+                <a:solidFill>
+                  <a:srgbClr val="2C3E50"/>
+                </a:solidFill>
+              </a:defRPr>
+            </a:pPr>
+          </a:p>
+          <a:p>
+            <a:pPr>
+              <a:spcBef>
+                <a:spcPts val="1200"/>
+              </a:spcBef>
+              <a:defRPr sz="1800">
+                <a:solidFill>
+                  <a:srgbClr val="2C3E50"/>
+                </a:solidFill>
+              </a:defRPr>
+            </a:pPr>
+            <a:r>
+              <a:t>Q: 交換要花多少錢？</a:t>
+            </a:r>
+          </a:p>
+          <a:p>
+            <a:pPr>
+              <a:spcBef>
+                <a:spcPts val="1200"/>
+              </a:spcBef>
+              <a:defRPr sz="1800">
+                <a:solidFill>
+                  <a:srgbClr val="2C3E50"/>
+                </a:solidFill>
+              </a:defRPr>
+            </a:pPr>
+            <a:r>
+              <a:t>A: 視國家而定。學海計畫補助5-30萬，力學優秀生可全額。</a:t>
+            </a:r>
+          </a:p>
+          <a:p>
+            <a:pPr>
+              <a:spcBef>
+                <a:spcPts val="1200"/>
+              </a:spcBef>
+              <a:defRPr sz="1800">
+                <a:solidFill>
+                  <a:srgbClr val="2C3E50"/>
+                </a:solidFill>
+              </a:defRPr>
+            </a:pPr>
+          </a:p>
+          <a:p>
+            <a:pPr>
+              <a:spcBef>
+                <a:spcPts val="1200"/>
+              </a:spcBef>
+              <a:defRPr sz="1800">
+                <a:solidFill>
+                  <a:srgbClr val="2C3E50"/>
+                </a:solidFill>
+              </a:defRPr>
+            </a:pPr>
+            <a:r>
+              <a:t>Q: 現在開始準備來得及嗎？</a:t>
+            </a:r>
+          </a:p>
+          <a:p>
+            <a:pPr>
+              <a:spcBef>
+                <a:spcPts val="1200"/>
+              </a:spcBef>
+              <a:defRPr sz="1800">
+                <a:solidFill>
+                  <a:srgbClr val="2C3E50"/>
+                </a:solidFill>
+              </a:defRPr>
+            </a:pPr>
+            <a:r>
+              <a:t>A: 看你想何時出發。至少需要12個月準備時間。</a:t>
             </a:r>
           </a:p>
         </p:txBody>
@@ -6317,7 +6317,7 @@
               </a:defRPr>
             </a:pPr>
             <a:r>
-              <a:t>🌍 The world is your classroom. 🌍</a:t>
+              <a:t>The world is your classroom.</a:t>
             </a:r>
           </a:p>
         </p:txBody>
@@ -6451,52 +6451,52 @@
               </a:defRPr>
             </a:pPr>
             <a:r>
-              <a:t>✓ 身為百川人，校級交換管道受限</a:t>
-            </a:r>
-          </a:p>
-          <a:p>
-            <a:pPr>
-              <a:spcBef>
-                <a:spcPts val="1200"/>
-              </a:spcBef>
-              <a:defRPr sz="1800">
-                <a:solidFill>
-                  <a:srgbClr val="2C3E50"/>
-                </a:solidFill>
-              </a:defRPr>
-            </a:pPr>
-            <a:r>
-              <a:t>✓ 需自行開闢外軌途徑（如教育部獎學金）</a:t>
-            </a:r>
-          </a:p>
-          <a:p>
-            <a:pPr>
-              <a:spcBef>
-                <a:spcPts val="1200"/>
-              </a:spcBef>
-              <a:defRPr sz="1800">
-                <a:solidFill>
-                  <a:srgbClr val="2C3E50"/>
-                </a:solidFill>
-              </a:defRPr>
-            </a:pPr>
-            <a:r>
-              <a:t>✓ 跨領域背景 = 國際競爭力的優勢</a:t>
-            </a:r>
-          </a:p>
-          <a:p>
-            <a:pPr>
-              <a:spcBef>
-                <a:spcPts val="1200"/>
-              </a:spcBef>
-              <a:defRPr sz="1800">
-                <a:solidFill>
-                  <a:srgbClr val="2C3E50"/>
-                </a:solidFill>
-              </a:defRPr>
-            </a:pPr>
-            <a:r>
-              <a:t>✓ 全球化視野對百川人的職涯發展至關重要</a:t>
+              <a:t>• 身為百川人，校級交換管道受限</a:t>
+            </a:r>
+          </a:p>
+          <a:p>
+            <a:pPr>
+              <a:spcBef>
+                <a:spcPts val="1200"/>
+              </a:spcBef>
+              <a:defRPr sz="1800">
+                <a:solidFill>
+                  <a:srgbClr val="2C3E50"/>
+                </a:solidFill>
+              </a:defRPr>
+            </a:pPr>
+            <a:r>
+              <a:t>• 需自行開闢外軌途徑（如教育部獎學金）</a:t>
+            </a:r>
+          </a:p>
+          <a:p>
+            <a:pPr>
+              <a:spcBef>
+                <a:spcPts val="1200"/>
+              </a:spcBef>
+              <a:defRPr sz="1800">
+                <a:solidFill>
+                  <a:srgbClr val="2C3E50"/>
+                </a:solidFill>
+              </a:defRPr>
+            </a:pPr>
+            <a:r>
+              <a:t>• 跨領域背景 = 國際競爭力的優勢</a:t>
+            </a:r>
+          </a:p>
+          <a:p>
+            <a:pPr>
+              <a:spcBef>
+                <a:spcPts val="1200"/>
+              </a:spcBef>
+              <a:defRPr sz="1800">
+                <a:solidFill>
+                  <a:srgbClr val="2C3E50"/>
+                </a:solidFill>
+              </a:defRPr>
+            </a:pPr>
+            <a:r>
+              <a:t>• 全球化視野對百川人的職涯發展至關重要</a:t>
             </a:r>
           </a:p>
           <a:p>
@@ -6523,7 +6523,7 @@
               </a:defRPr>
             </a:pPr>
             <a:r>
-              <a:t>💡 挑戰：如何在有限資源下，找到屬於自己的路？</a:t>
+              <a:t>【挑戰】如何在有限資源下，找到屬於自己的路？</a:t>
             </a:r>
           </a:p>
         </p:txBody>
@@ -6657,97 +6657,97 @@
               </a:defRPr>
             </a:pPr>
             <a:r>
-              <a:t>📅 12-18個月前：決定目標、開始研究國家/學校</a:t>
-            </a:r>
-          </a:p>
-          <a:p>
-            <a:pPr>
-              <a:spcBef>
-                <a:spcPts val="1200"/>
-              </a:spcBef>
-              <a:defRPr sz="1800">
-                <a:solidFill>
-                  <a:srgbClr val="2C3E50"/>
-                </a:solidFill>
-              </a:defRPr>
-            </a:pPr>
-            <a:r>
-              <a:t>📅 10-12個月前：準備英文考試（托福/雅思）、提升GPA</a:t>
-            </a:r>
-          </a:p>
-          <a:p>
-            <a:pPr>
-              <a:spcBef>
-                <a:spcPts val="1200"/>
-              </a:spcBef>
-              <a:defRPr sz="1800">
-                <a:solidFill>
-                  <a:srgbClr val="2C3E50"/>
-                </a:solidFill>
-              </a:defRPr>
-            </a:pPr>
-            <a:r>
-              <a:t>📅 8-10個月前：撰寫研究計畫、爭取教授邀請函</a:t>
-            </a:r>
-          </a:p>
-          <a:p>
-            <a:pPr>
-              <a:spcBef>
-                <a:spcPts val="1200"/>
-              </a:spcBef>
-              <a:defRPr sz="1800">
-                <a:solidFill>
-                  <a:srgbClr val="2C3E50"/>
-                </a:solidFill>
-              </a:defRPr>
-            </a:pPr>
-            <a:r>
-              <a:t>📅 6-8個月前：申請獎學金（學海計畫等）</a:t>
-            </a:r>
-          </a:p>
-          <a:p>
-            <a:pPr>
-              <a:spcBef>
-                <a:spcPts val="1200"/>
-              </a:spcBef>
-              <a:defRPr sz="1800">
-                <a:solidFill>
-                  <a:srgbClr val="2C3E50"/>
-                </a:solidFill>
-              </a:defRPr>
-            </a:pPr>
-            <a:r>
-              <a:t>📅 4-6個月前：申請學校、準備申請文件</a:t>
-            </a:r>
-          </a:p>
-          <a:p>
-            <a:pPr>
-              <a:spcBef>
-                <a:spcPts val="1200"/>
-              </a:spcBef>
-              <a:defRPr sz="1800">
-                <a:solidFill>
-                  <a:srgbClr val="2C3E50"/>
-                </a:solidFill>
-              </a:defRPr>
-            </a:pPr>
-            <a:r>
-              <a:t>📅 2-4個月前：申請簽證（德國需2個月！）</a:t>
-            </a:r>
-          </a:p>
-          <a:p>
-            <a:pPr>
-              <a:spcBef>
-                <a:spcPts val="1200"/>
-              </a:spcBef>
-              <a:defRPr sz="1800">
-                <a:solidFill>
-                  <a:srgbClr val="2C3E50"/>
-                </a:solidFill>
-              </a:defRPr>
-            </a:pPr>
-            <a:r>
-              <a:t>📅 1-2個月前：訂機票、保險、住宿、網卡</a:t>
+              <a:t>▸ 12-18個月前：決定目標、開始研究國家/學校</a:t>
+            </a:r>
+          </a:p>
+          <a:p>
+            <a:pPr>
+              <a:spcBef>
+                <a:spcPts val="1200"/>
+              </a:spcBef>
+              <a:defRPr sz="1800">
+                <a:solidFill>
+                  <a:srgbClr val="2C3E50"/>
+                </a:solidFill>
+              </a:defRPr>
+            </a:pPr>
+            <a:r>
+              <a:t>▸ 10-12個月前：準備英文考試（托福/雅思）、提升GPA</a:t>
+            </a:r>
+          </a:p>
+          <a:p>
+            <a:pPr>
+              <a:spcBef>
+                <a:spcPts val="1200"/>
+              </a:spcBef>
+              <a:defRPr sz="1800">
+                <a:solidFill>
+                  <a:srgbClr val="2C3E50"/>
+                </a:solidFill>
+              </a:defRPr>
+            </a:pPr>
+            <a:r>
+              <a:t>▸ 8-10個月前：撰寫研究計畫、爭取教授邀請函</a:t>
+            </a:r>
+          </a:p>
+          <a:p>
+            <a:pPr>
+              <a:spcBef>
+                <a:spcPts val="1200"/>
+              </a:spcBef>
+              <a:defRPr sz="1800">
+                <a:solidFill>
+                  <a:srgbClr val="2C3E50"/>
+                </a:solidFill>
+              </a:defRPr>
+            </a:pPr>
+            <a:r>
+              <a:t>▸ 6-8個月前：申請獎學金（學海計畫等）</a:t>
+            </a:r>
+          </a:p>
+          <a:p>
+            <a:pPr>
+              <a:spcBef>
+                <a:spcPts val="1200"/>
+              </a:spcBef>
+              <a:defRPr sz="1800">
+                <a:solidFill>
+                  <a:srgbClr val="2C3E50"/>
+                </a:solidFill>
+              </a:defRPr>
+            </a:pPr>
+            <a:r>
+              <a:t>▸ 4-6個月前：申請學校、準備申請文件</a:t>
+            </a:r>
+          </a:p>
+          <a:p>
+            <a:pPr>
+              <a:spcBef>
+                <a:spcPts val="1200"/>
+              </a:spcBef>
+              <a:defRPr sz="1800">
+                <a:solidFill>
+                  <a:srgbClr val="2C3E50"/>
+                </a:solidFill>
+              </a:defRPr>
+            </a:pPr>
+            <a:r>
+              <a:t>▸ 2-4個月前：申請簽證（德國需2個月！）</a:t>
+            </a:r>
+          </a:p>
+          <a:p>
+            <a:pPr>
+              <a:spcBef>
+                <a:spcPts val="1200"/>
+              </a:spcBef>
+              <a:defRPr sz="1800">
+                <a:solidFill>
+                  <a:srgbClr val="2C3E50"/>
+                </a:solidFill>
+              </a:defRPr>
+            </a:pPr>
+            <a:r>
+              <a:t>▸ 1-2個月前：訂機票、保險、住宿、網卡</a:t>
             </a:r>
           </a:p>
           <a:p>
@@ -6774,7 +6774,7 @@
               </a:defRPr>
             </a:pPr>
             <a:r>
-              <a:t>⚠️ 越早開始，選擇越多！</a:t>
+              <a:t>【重要】越早開始，選擇越多！</a:t>
             </a:r>
           </a:p>
         </p:txBody>
@@ -6862,7 +6862,7 @@
               </a:defRPr>
             </a:pPr>
             <a:r>
-              <a:t>🎯 玩樂導向</a:t>
+              <a:t>類型一：玩樂導向</a:t>
             </a:r>
           </a:p>
         </p:txBody>
@@ -6900,7 +6900,7 @@
               </a:defRPr>
             </a:pPr>
             <a:r>
-              <a:t>🎒 以旅遊玩樂為主</a:t>
+              <a:t>【玩樂導向】以旅遊玩樂為主</a:t>
             </a:r>
           </a:p>
           <a:p>
@@ -6987,7 +6987,7 @@
               </a:defRPr>
             </a:pPr>
             <a:r>
-              <a:t>⚖️ 平衡型</a:t>
+              <a:t>【平衡型】</a:t>
             </a:r>
           </a:p>
           <a:p>
@@ -7067,7 +7067,7 @@
               </a:defRPr>
             </a:pPr>
             <a:r>
-              <a:t>🎯 進修導向</a:t>
+              <a:t>類型二：進修導向</a:t>
             </a:r>
           </a:p>
         </p:txBody>
@@ -7105,7 +7105,7 @@
               </a:defRPr>
             </a:pPr>
             <a:r>
-              <a:t>📚 以學術進修為重</a:t>
+              <a:t>【進修導向】以學術進修為重</a:t>
             </a:r>
           </a:p>
           <a:p>
@@ -7192,7 +7192,7 @@
               </a:defRPr>
             </a:pPr>
             <a:r>
-              <a:t>💡 重要提醒</a:t>
+              <a:t>【重要提醒】</a:t>
             </a:r>
           </a:p>
           <a:p>
@@ -7371,7 +7371,7 @@
               </a:defRPr>
             </a:pPr>
             <a:r>
-              <a:t>1️⃣ 英文能力（最重要！可提前準備）</a:t>
+              <a:t>一、英文能力（最重要！可提前準備）</a:t>
             </a:r>
           </a:p>
           <a:p>
@@ -7443,7 +7443,7 @@
               </a:defRPr>
             </a:pPr>
             <a:r>
-              <a:t>2️⃣ 在校成績 GPA（可量化指標）</a:t>
+              <a:t>二、在校成績 GPA（可量化指標）</a:t>
             </a:r>
           </a:p>
           <a:p>
@@ -7500,7 +7500,7 @@
               </a:defRPr>
             </a:pPr>
             <a:r>
-              <a:t>3️⃣ 動機與研究計畫（展現熱忱）</a:t>
+              <a:t>三、動機與研究計畫（展現熱忱）</a:t>
             </a:r>
           </a:p>
           <a:p>
@@ -7694,7 +7694,7 @@
               </a:defRPr>
             </a:pPr>
             <a:r>
-              <a:t>🎓 教育部學海計畫（大學交換）</a:t>
+              <a:t>【A】教育部學海計畫（大學交換）</a:t>
             </a:r>
           </a:p>
           <a:p>
@@ -7766,7 +7766,7 @@
               </a:defRPr>
             </a:pPr>
             <a:r>
-              <a:t>🎓 赴捷克短期進修獎學金（我的案例）</a:t>
+              <a:t>【B】赴捷克短期進修獎學金（我的案例）</a:t>
             </a:r>
           </a:p>
           <a:p>
@@ -7826,34 +7826,34 @@
               </a:defRPr>
             </a:pPr>
             <a:r>
-              <a:t>   • ⚠️ 風險：台灣錄取 ≠ 捷克最終核准</a:t>
-            </a:r>
-          </a:p>
-          <a:p>
-            <a:pPr>
-              <a:spcBef>
-                <a:spcPts val="1200"/>
-              </a:spcBef>
-              <a:defRPr sz="1800">
-                <a:solidFill>
-                  <a:srgbClr val="2C3E50"/>
-                </a:solidFill>
-              </a:defRPr>
-            </a:pPr>
-          </a:p>
-          <a:p>
-            <a:pPr>
-              <a:spcBef>
-                <a:spcPts val="1200"/>
-              </a:spcBef>
-              <a:defRPr sz="1800">
-                <a:solidFill>
-                  <a:srgbClr val="2C3E50"/>
-                </a:solidFill>
-              </a:defRPr>
-            </a:pPr>
-            <a:r>
-              <a:t>🎓 其他選項</a:t>
+              <a:t>   • 注意：台灣錄取 ≠ 捷克最終核准</a:t>
+            </a:r>
+          </a:p>
+          <a:p>
+            <a:pPr>
+              <a:spcBef>
+                <a:spcPts val="1200"/>
+              </a:spcBef>
+              <a:defRPr sz="1800">
+                <a:solidFill>
+                  <a:srgbClr val="2C3E50"/>
+                </a:solidFill>
+              </a:defRPr>
+            </a:pPr>
+          </a:p>
+          <a:p>
+            <a:pPr>
+              <a:spcBef>
+                <a:spcPts val="1200"/>
+              </a:spcBef>
+              <a:defRPr sz="1800">
+                <a:solidFill>
+                  <a:srgbClr val="2C3E50"/>
+                </a:solidFill>
+              </a:defRPr>
+            </a:pPr>
+            <a:r>
+              <a:t>【C】其他選項</a:t>
             </a:r>
           </a:p>
           <a:p>
@@ -8017,166 +8017,166 @@
               </a:defRPr>
             </a:pPr>
             <a:r>
-              <a:t>🌍 考量因素清單：</a:t>
-            </a:r>
-          </a:p>
-          <a:p>
-            <a:pPr>
-              <a:spcBef>
-                <a:spcPts val="1200"/>
-              </a:spcBef>
-              <a:defRPr sz="1800">
-                <a:solidFill>
-                  <a:srgbClr val="2C3E50"/>
-                </a:solidFill>
-              </a:defRPr>
-            </a:pPr>
-          </a:p>
-          <a:p>
-            <a:pPr>
-              <a:spcBef>
-                <a:spcPts val="1200"/>
-              </a:spcBef>
-              <a:defRPr sz="1800">
-                <a:solidFill>
-                  <a:srgbClr val="2C3E50"/>
-                </a:solidFill>
-              </a:defRPr>
-            </a:pPr>
-            <a:r>
-              <a:t>✓ 生活成本（東歐&lt;西歐&lt;北美）</a:t>
-            </a:r>
-          </a:p>
-          <a:p>
-            <a:pPr>
-              <a:spcBef>
-                <a:spcPts val="1200"/>
-              </a:spcBef>
-              <a:defRPr sz="1800">
-                <a:solidFill>
-                  <a:srgbClr val="2C3E50"/>
-                </a:solidFill>
-              </a:defRPr>
-            </a:pPr>
-            <a:r>
-              <a:t>✓ 交通便利性（旅遊需求）</a:t>
-            </a:r>
-          </a:p>
-          <a:p>
-            <a:pPr>
-              <a:spcBef>
-                <a:spcPts val="1200"/>
-              </a:spcBef>
-              <a:defRPr sz="1800">
-                <a:solidFill>
-                  <a:srgbClr val="2C3E50"/>
-                </a:solidFill>
-              </a:defRPr>
-            </a:pPr>
-            <a:r>
-              <a:t>✓ 學術資源（進修需求）</a:t>
-            </a:r>
-          </a:p>
-          <a:p>
-            <a:pPr>
-              <a:spcBef>
-                <a:spcPts val="1200"/>
-              </a:spcBef>
-              <a:defRPr sz="1800">
-                <a:solidFill>
-                  <a:srgbClr val="2C3E50"/>
-                </a:solidFill>
-              </a:defRPr>
-            </a:pPr>
-            <a:r>
-              <a:t>✓ 語言障礙程度（英語普及度）</a:t>
-            </a:r>
-          </a:p>
-          <a:p>
-            <a:pPr>
-              <a:spcBef>
-                <a:spcPts val="1200"/>
-              </a:spcBef>
-              <a:defRPr sz="1800">
-                <a:solidFill>
-                  <a:srgbClr val="2C3E50"/>
-                </a:solidFill>
-              </a:defRPr>
-            </a:pPr>
-            <a:r>
-              <a:t>✓ 行政效率（歐洲普遍較慢，需心理準備）</a:t>
-            </a:r>
-          </a:p>
-          <a:p>
-            <a:pPr>
-              <a:spcBef>
-                <a:spcPts val="1200"/>
-              </a:spcBef>
-              <a:defRPr sz="1800">
-                <a:solidFill>
-                  <a:srgbClr val="2C3E50"/>
-                </a:solidFill>
-              </a:defRPr>
-            </a:pPr>
-            <a:r>
-              <a:t>✓ 地緣關係（未來就業考量）</a:t>
-            </a:r>
-          </a:p>
-          <a:p>
-            <a:pPr>
-              <a:spcBef>
-                <a:spcPts val="1200"/>
-              </a:spcBef>
-              <a:defRPr sz="1800">
-                <a:solidFill>
-                  <a:srgbClr val="2C3E50"/>
-                </a:solidFill>
-              </a:defRPr>
-            </a:pPr>
-            <a:r>
-              <a:t>✓ 氣候與日照（11月後歐洲4點天黑，易憂鬱）</a:t>
-            </a:r>
-          </a:p>
-          <a:p>
-            <a:pPr>
-              <a:spcBef>
-                <a:spcPts val="1200"/>
-              </a:spcBef>
-              <a:defRPr sz="1800">
-                <a:solidFill>
-                  <a:srgbClr val="2C3E50"/>
-                </a:solidFill>
-              </a:defRPr>
-            </a:pPr>
-            <a:r>
-              <a:t>✓ 簽證難度（德國2個月 vs 日本3天）</a:t>
-            </a:r>
-          </a:p>
-          <a:p>
-            <a:pPr>
-              <a:spcBef>
-                <a:spcPts val="1200"/>
-              </a:spcBef>
-              <a:defRPr sz="1800">
-                <a:solidFill>
-                  <a:srgbClr val="2C3E50"/>
-                </a:solidFill>
-              </a:defRPr>
-            </a:pPr>
-          </a:p>
-          <a:p>
-            <a:pPr>
-              <a:spcBef>
-                <a:spcPts val="1200"/>
-              </a:spcBef>
-              <a:defRPr sz="1800">
-                <a:solidFill>
-                  <a:srgbClr val="2C3E50"/>
-                </a:solidFill>
-              </a:defRPr>
-            </a:pPr>
-            <a:r>
-              <a:t>💡 特殊領域提醒：</a:t>
+              <a:t>考量因素清單：</a:t>
+            </a:r>
+          </a:p>
+          <a:p>
+            <a:pPr>
+              <a:spcBef>
+                <a:spcPts val="1200"/>
+              </a:spcBef>
+              <a:defRPr sz="1800">
+                <a:solidFill>
+                  <a:srgbClr val="2C3E50"/>
+                </a:solidFill>
+              </a:defRPr>
+            </a:pPr>
+          </a:p>
+          <a:p>
+            <a:pPr>
+              <a:spcBef>
+                <a:spcPts val="1200"/>
+              </a:spcBef>
+              <a:defRPr sz="1800">
+                <a:solidFill>
+                  <a:srgbClr val="2C3E50"/>
+                </a:solidFill>
+              </a:defRPr>
+            </a:pPr>
+            <a:r>
+              <a:t>• 生活成本（東歐&lt;西歐&lt;北美）</a:t>
+            </a:r>
+          </a:p>
+          <a:p>
+            <a:pPr>
+              <a:spcBef>
+                <a:spcPts val="1200"/>
+              </a:spcBef>
+              <a:defRPr sz="1800">
+                <a:solidFill>
+                  <a:srgbClr val="2C3E50"/>
+                </a:solidFill>
+              </a:defRPr>
+            </a:pPr>
+            <a:r>
+              <a:t>• 交通便利性（旅遊需求）</a:t>
+            </a:r>
+          </a:p>
+          <a:p>
+            <a:pPr>
+              <a:spcBef>
+                <a:spcPts val="1200"/>
+              </a:spcBef>
+              <a:defRPr sz="1800">
+                <a:solidFill>
+                  <a:srgbClr val="2C3E50"/>
+                </a:solidFill>
+              </a:defRPr>
+            </a:pPr>
+            <a:r>
+              <a:t>• 學術資源（進修需求）</a:t>
+            </a:r>
+          </a:p>
+          <a:p>
+            <a:pPr>
+              <a:spcBef>
+                <a:spcPts val="1200"/>
+              </a:spcBef>
+              <a:defRPr sz="1800">
+                <a:solidFill>
+                  <a:srgbClr val="2C3E50"/>
+                </a:solidFill>
+              </a:defRPr>
+            </a:pPr>
+            <a:r>
+              <a:t>• 語言障礙程度（英語普及度）</a:t>
+            </a:r>
+          </a:p>
+          <a:p>
+            <a:pPr>
+              <a:spcBef>
+                <a:spcPts val="1200"/>
+              </a:spcBef>
+              <a:defRPr sz="1800">
+                <a:solidFill>
+                  <a:srgbClr val="2C3E50"/>
+                </a:solidFill>
+              </a:defRPr>
+            </a:pPr>
+            <a:r>
+              <a:t>• 行政效率（歐洲普遍較慢，需心理準備）</a:t>
+            </a:r>
+          </a:p>
+          <a:p>
+            <a:pPr>
+              <a:spcBef>
+                <a:spcPts val="1200"/>
+              </a:spcBef>
+              <a:defRPr sz="1800">
+                <a:solidFill>
+                  <a:srgbClr val="2C3E50"/>
+                </a:solidFill>
+              </a:defRPr>
+            </a:pPr>
+            <a:r>
+              <a:t>• 地緣關係（未來就業考量）</a:t>
+            </a:r>
+          </a:p>
+          <a:p>
+            <a:pPr>
+              <a:spcBef>
+                <a:spcPts val="1200"/>
+              </a:spcBef>
+              <a:defRPr sz="1800">
+                <a:solidFill>
+                  <a:srgbClr val="2C3E50"/>
+                </a:solidFill>
+              </a:defRPr>
+            </a:pPr>
+            <a:r>
+              <a:t>• 氣候與日照（11月後歐洲4點天黑，易憂鬱）</a:t>
+            </a:r>
+          </a:p>
+          <a:p>
+            <a:pPr>
+              <a:spcBef>
+                <a:spcPts val="1200"/>
+              </a:spcBef>
+              <a:defRPr sz="1800">
+                <a:solidFill>
+                  <a:srgbClr val="2C3E50"/>
+                </a:solidFill>
+              </a:defRPr>
+            </a:pPr>
+            <a:r>
+              <a:t>• 簽證難度（德國2個月 vs 日本3天）</a:t>
+            </a:r>
+          </a:p>
+          <a:p>
+            <a:pPr>
+              <a:spcBef>
+                <a:spcPts val="1200"/>
+              </a:spcBef>
+              <a:defRPr sz="1800">
+                <a:solidFill>
+                  <a:srgbClr val="2C3E50"/>
+                </a:solidFill>
+              </a:defRPr>
+            </a:pPr>
+          </a:p>
+          <a:p>
+            <a:pPr>
+              <a:spcBef>
+                <a:spcPts val="1200"/>
+              </a:spcBef>
+              <a:defRPr sz="1800">
+                <a:solidFill>
+                  <a:srgbClr val="2C3E50"/>
+                </a:solidFill>
+              </a:defRPr>
+            </a:pPr>
+            <a:r>
+              <a:t>特殊領域提醒：</a:t>
             </a:r>
           </a:p>
           <a:p>
@@ -8294,7 +8294,7 @@
               </a:defRPr>
             </a:pPr>
             <a:r>
-              <a:t>📄 必備項目</a:t>
+              <a:t>必備項目</a:t>
             </a:r>
           </a:p>
         </p:txBody>
@@ -8332,7 +8332,7 @@
               </a:defRPr>
             </a:pPr>
             <a:r>
-              <a:t>📋 文件類</a:t>
+              <a:t>【文件類】</a:t>
             </a:r>
           </a:p>
           <a:p>
@@ -8347,7 +8347,7 @@
               </a:defRPr>
             </a:pPr>
             <a:r>
-              <a:t>✓ 簽證（提早2-3個月辦理）</a:t>
+              <a:t>• 簽證（提早2-3個月辦理）</a:t>
             </a:r>
           </a:p>
           <a:p>
@@ -8362,7 +8362,7 @@
               </a:defRPr>
             </a:pPr>
             <a:r>
-              <a:t>✓ 護照效期（需超過6個月）</a:t>
+              <a:t>• 護照效期（需超過6個月）</a:t>
             </a:r>
           </a:p>
           <a:p>
@@ -8377,7 +8377,7 @@
               </a:defRPr>
             </a:pPr>
             <a:r>
-              <a:t>✓ 國際學生證 ISIC（歐洲很好用）</a:t>
+              <a:t>• 國際學生證 ISIC（歐洲很好用）</a:t>
             </a:r>
           </a:p>
           <a:p>
@@ -8392,7 +8392,7 @@
               </a:defRPr>
             </a:pPr>
             <a:r>
-              <a:t>✓ 英文版成績單、在學證明</a:t>
+              <a:t>• 英文版成績單、在學證明</a:t>
             </a:r>
           </a:p>
           <a:p>
@@ -8419,7 +8419,7 @@
               </a:defRPr>
             </a:pPr>
             <a:r>
-              <a:t>💰 財務類</a:t>
+              <a:t>【財務類】</a:t>
             </a:r>
           </a:p>
           <a:p>
@@ -8434,7 +8434,7 @@
               </a:defRPr>
             </a:pPr>
             <a:r>
-              <a:t>✓ 至少2張信用卡（備援）</a:t>
+              <a:t>• 至少2張信用卡（備援）</a:t>
             </a:r>
           </a:p>
           <a:p>
@@ -8449,7 +8449,7 @@
               </a:defRPr>
             </a:pPr>
             <a:r>
-              <a:t>✓ 了解ATM提款機制</a:t>
+              <a:t>• 了解ATM提款機制</a:t>
             </a:r>
           </a:p>
           <a:p>
@@ -8464,7 +8464,7 @@
               </a:defRPr>
             </a:pPr>
             <a:r>
-              <a:t>✓ 換一些現金在身上</a:t>
+              <a:t>• 換一些現金在身上</a:t>
             </a:r>
           </a:p>
           <a:p>
@@ -8479,7 +8479,7 @@
               </a:defRPr>
             </a:pPr>
             <a:r>
-              <a:t>✓ 保險（醫療費用超貴！）</a:t>
+              <a:t>• 保險（醫療費用超貴！）</a:t>
             </a:r>
           </a:p>
         </p:txBody>
@@ -8514,7 +8514,7 @@
               </a:defRPr>
             </a:pPr>
             <a:r>
-              <a:t>🔧 實用工具</a:t>
+              <a:t>實用工具</a:t>
             </a:r>
           </a:p>
         </p:txBody>
@@ -8552,7 +8552,7 @@
               </a:defRPr>
             </a:pPr>
             <a:r>
-              <a:t>📱 生活類</a:t>
+              <a:t>【生活類】</a:t>
             </a:r>
           </a:p>
           <a:p>
@@ -8567,7 +8567,7 @@
               </a:defRPr>
             </a:pPr>
             <a:r>
-              <a:t>✓ 網卡/SIM卡（必備！）</a:t>
+              <a:t>• 網卡/SIM卡（必備！）</a:t>
             </a:r>
           </a:p>
           <a:p>
@@ -8582,7 +8582,7 @@
               </a:defRPr>
             </a:pPr>
             <a:r>
-              <a:t>✓ 翻譯軟體（非英語系國家）</a:t>
+              <a:t>• 翻譯軟體（非英語系國家）</a:t>
             </a:r>
           </a:p>
           <a:p>
@@ -8597,7 +8597,7 @@
               </a:defRPr>
             </a:pPr>
             <a:r>
-              <a:t>✓ 正裝西裝（歐洲考試/活動需要）</a:t>
+              <a:t>• 正裝西裝（歐洲考試/活動需要）</a:t>
             </a:r>
           </a:p>
           <a:p>
@@ -8612,7 +8612,7 @@
               </a:defRPr>
             </a:pPr>
             <a:r>
-              <a:t>✓ 消費電子產品在台灣買（歐洲VAT 15-19%）</a:t>
+              <a:t>• 消費電子產品在台灣買（歐洲VAT 15-19%）</a:t>
             </a:r>
           </a:p>
           <a:p>
@@ -8639,7 +8639,7 @@
               </a:defRPr>
             </a:pPr>
             <a:r>
-              <a:t>📚 行政類</a:t>
+              <a:t>【行政類】</a:t>
             </a:r>
           </a:p>
           <a:p>
@@ -8654,7 +8654,7 @@
               </a:defRPr>
             </a:pPr>
             <a:r>
-              <a:t>✓ 確認選課與住宿</a:t>
+              <a:t>• 確認選課與住宿</a:t>
             </a:r>
           </a:p>
           <a:p>
@@ -8669,7 +8669,7 @@
               </a:defRPr>
             </a:pPr>
             <a:r>
-              <a:t>✓ 查詢國定假日（避免落地遇假期）</a:t>
+              <a:t>• 查詢國定假日（避免落地遇假期）</a:t>
             </a:r>
           </a:p>
           <a:p>
@@ -8684,7 +8684,7 @@
               </a:defRPr>
             </a:pPr>
             <a:r>
-              <a:t>✓ 了解「銀行週」時間</a:t>
+              <a:t>• 了解「銀行週」時間</a:t>
             </a:r>
           </a:p>
           <a:p>
@@ -8699,7 +8699,7 @@
               </a:defRPr>
             </a:pPr>
             <a:r>
-              <a:t>✓ 加入當地留學生社團（FB/Line）</a:t>
+              <a:t>• 加入當地留學生社團（FB/Line）</a:t>
             </a:r>
           </a:p>
         </p:txBody>
@@ -8833,196 +8833,196 @@
               </a:defRPr>
             </a:pPr>
             <a:r>
-              <a:t>💡 省錢策略：</a:t>
-            </a:r>
-          </a:p>
-          <a:p>
-            <a:pPr>
-              <a:spcBef>
-                <a:spcPts val="1200"/>
-              </a:spcBef>
-              <a:defRPr sz="1800">
-                <a:solidFill>
-                  <a:srgbClr val="2C3E50"/>
-                </a:solidFill>
-              </a:defRPr>
-            </a:pPr>
-            <a:r>
-              <a:t>✓ 歐洲VAT高（15-19%），貴重3C在台灣買（相機、耳機、GoPro）</a:t>
-            </a:r>
-          </a:p>
-          <a:p>
-            <a:pPr>
-              <a:spcBef>
-                <a:spcPts val="1200"/>
-              </a:spcBef>
-              <a:defRPr sz="1800">
-                <a:solidFill>
-                  <a:srgbClr val="2C3E50"/>
-                </a:solidFill>
-              </a:defRPr>
-            </a:pPr>
-            <a:r>
-              <a:t>✓ 使用AI工具時掛VPN回台灣刷卡（避免歐盟VAT）</a:t>
-            </a:r>
-          </a:p>
-          <a:p>
-            <a:pPr>
-              <a:spcBef>
-                <a:spcPts val="1200"/>
-              </a:spcBef>
-              <a:defRPr sz="1800">
-                <a:solidFill>
-                  <a:srgbClr val="2C3E50"/>
-                </a:solidFill>
-              </a:defRPr>
-            </a:pPr>
-            <a:r>
-              <a:t>✓ 了解各國退稅門檻與流程</a:t>
-            </a:r>
-          </a:p>
-          <a:p>
-            <a:pPr>
-              <a:spcBef>
-                <a:spcPts val="1200"/>
-              </a:spcBef>
-              <a:defRPr sz="1800">
-                <a:solidFill>
-                  <a:srgbClr val="2C3E50"/>
-                </a:solidFill>
-              </a:defRPr>
-            </a:pPr>
-            <a:r>
-              <a:t>✓ 學會煮飯（外食比台北貴）</a:t>
-            </a:r>
-          </a:p>
-          <a:p>
-            <a:pPr>
-              <a:spcBef>
-                <a:spcPts val="1200"/>
-              </a:spcBef>
-              <a:defRPr sz="1800">
-                <a:solidFill>
-                  <a:srgbClr val="2C3E50"/>
-                </a:solidFill>
-              </a:defRPr>
-            </a:pPr>
-            <a:r>
-              <a:t>✓ 購買月票/季票（德國49歐月票超划算）</a:t>
-            </a:r>
-          </a:p>
-          <a:p>
-            <a:pPr>
-              <a:spcBef>
-                <a:spcPts val="1200"/>
-              </a:spcBef>
-              <a:defRPr sz="1800">
-                <a:solidFill>
-                  <a:srgbClr val="2C3E50"/>
-                </a:solidFill>
-              </a:defRPr>
-            </a:pPr>
-          </a:p>
-          <a:p>
-            <a:pPr>
-              <a:spcBef>
-                <a:spcPts val="1200"/>
-              </a:spcBef>
-              <a:defRPr sz="1800">
-                <a:solidFill>
-                  <a:srgbClr val="2C3E50"/>
-                </a:solidFill>
-              </a:defRPr>
-            </a:pPr>
-            <a:r>
-              <a:t>⚠️ 常見陷阱：</a:t>
-            </a:r>
-          </a:p>
-          <a:p>
-            <a:pPr>
-              <a:spcBef>
-                <a:spcPts val="1200"/>
-              </a:spcBef>
-              <a:defRPr sz="1800">
-                <a:solidFill>
-                  <a:srgbClr val="2C3E50"/>
-                </a:solidFill>
-              </a:defRPr>
-            </a:pPr>
-            <a:r>
-              <a:t>✗ 一次付清代辦費（建議分期，信用卡付款可追回）</a:t>
-            </a:r>
-          </a:p>
-          <a:p>
-            <a:pPr>
-              <a:spcBef>
-                <a:spcPts val="1200"/>
-              </a:spcBef>
-              <a:defRPr sz="1800">
-                <a:solidFill>
-                  <a:srgbClr val="2C3E50"/>
-                </a:solidFill>
-              </a:defRPr>
-            </a:pPr>
-            <a:r>
-              <a:t>✗ 沒買保險（國外醫療費天價）</a:t>
-            </a:r>
-          </a:p>
-          <a:p>
-            <a:pPr>
-              <a:spcBef>
-                <a:spcPts val="1200"/>
-              </a:spcBef>
-              <a:defRPr sz="1800">
-                <a:solidFill>
-                  <a:srgbClr val="2C3E50"/>
-                </a:solidFill>
-              </a:defRPr>
-            </a:pPr>
-            <a:r>
-              <a:t>✗ 護照「Republic of China」問題（建議遮China或強調Taiwan）</a:t>
-            </a:r>
-          </a:p>
-          <a:p>
-            <a:pPr>
-              <a:spcBef>
-                <a:spcPts val="1200"/>
-              </a:spcBef>
-              <a:defRPr sz="1800">
-                <a:solidFill>
-                  <a:srgbClr val="2C3E50"/>
-                </a:solidFill>
-              </a:defRPr>
-            </a:pPr>
-            <a:r>
-              <a:t>✗ 被當中國人收保證金（辦電信時）</a:t>
-            </a:r>
-          </a:p>
-          <a:p>
-            <a:pPr>
-              <a:spcBef>
-                <a:spcPts val="1200"/>
-              </a:spcBef>
-              <a:defRPr sz="1800">
-                <a:solidFill>
-                  <a:srgbClr val="2C3E50"/>
-                </a:solidFill>
-              </a:defRPr>
-            </a:pPr>
-          </a:p>
-          <a:p>
-            <a:pPr>
-              <a:spcBef>
-                <a:spcPts val="1200"/>
-              </a:spcBef>
-              <a:defRPr sz="1800">
-                <a:solidFill>
-                  <a:srgbClr val="2C3E50"/>
-                </a:solidFill>
-              </a:defRPr>
-            </a:pPr>
-            <a:r>
-              <a:t>📞 申訴管道：台灣1950 / 國外找駐外機構</a:t>
+              <a:t>【省錢策略】</a:t>
+            </a:r>
+          </a:p>
+          <a:p>
+            <a:pPr>
+              <a:spcBef>
+                <a:spcPts val="1200"/>
+              </a:spcBef>
+              <a:defRPr sz="1800">
+                <a:solidFill>
+                  <a:srgbClr val="2C3E50"/>
+                </a:solidFill>
+              </a:defRPr>
+            </a:pPr>
+            <a:r>
+              <a:t>• 歐洲VAT高（15-19%），貴重3C在台灣買（相機、耳機、GoPro）</a:t>
+            </a:r>
+          </a:p>
+          <a:p>
+            <a:pPr>
+              <a:spcBef>
+                <a:spcPts val="1200"/>
+              </a:spcBef>
+              <a:defRPr sz="1800">
+                <a:solidFill>
+                  <a:srgbClr val="2C3E50"/>
+                </a:solidFill>
+              </a:defRPr>
+            </a:pPr>
+            <a:r>
+              <a:t>• 使用AI工具時掛VPN回台灣刷卡（避免歐盟VAT）</a:t>
+            </a:r>
+          </a:p>
+          <a:p>
+            <a:pPr>
+              <a:spcBef>
+                <a:spcPts val="1200"/>
+              </a:spcBef>
+              <a:defRPr sz="1800">
+                <a:solidFill>
+                  <a:srgbClr val="2C3E50"/>
+                </a:solidFill>
+              </a:defRPr>
+            </a:pPr>
+            <a:r>
+              <a:t>• 了解各國退稅門檻與流程</a:t>
+            </a:r>
+          </a:p>
+          <a:p>
+            <a:pPr>
+              <a:spcBef>
+                <a:spcPts val="1200"/>
+              </a:spcBef>
+              <a:defRPr sz="1800">
+                <a:solidFill>
+                  <a:srgbClr val="2C3E50"/>
+                </a:solidFill>
+              </a:defRPr>
+            </a:pPr>
+            <a:r>
+              <a:t>• 學會煮飯（外食比台北貴）</a:t>
+            </a:r>
+          </a:p>
+          <a:p>
+            <a:pPr>
+              <a:spcBef>
+                <a:spcPts val="1200"/>
+              </a:spcBef>
+              <a:defRPr sz="1800">
+                <a:solidFill>
+                  <a:srgbClr val="2C3E50"/>
+                </a:solidFill>
+              </a:defRPr>
+            </a:pPr>
+            <a:r>
+              <a:t>• 購買月票/季票（德國49歐月票超划算）</a:t>
+            </a:r>
+          </a:p>
+          <a:p>
+            <a:pPr>
+              <a:spcBef>
+                <a:spcPts val="1200"/>
+              </a:spcBef>
+              <a:defRPr sz="1800">
+                <a:solidFill>
+                  <a:srgbClr val="2C3E50"/>
+                </a:solidFill>
+              </a:defRPr>
+            </a:pPr>
+          </a:p>
+          <a:p>
+            <a:pPr>
+              <a:spcBef>
+                <a:spcPts val="1200"/>
+              </a:spcBef>
+              <a:defRPr sz="1800">
+                <a:solidFill>
+                  <a:srgbClr val="2C3E50"/>
+                </a:solidFill>
+              </a:defRPr>
+            </a:pPr>
+            <a:r>
+              <a:t>【常見陷阱】</a:t>
+            </a:r>
+          </a:p>
+          <a:p>
+            <a:pPr>
+              <a:spcBef>
+                <a:spcPts val="1200"/>
+              </a:spcBef>
+              <a:defRPr sz="1800">
+                <a:solidFill>
+                  <a:srgbClr val="2C3E50"/>
+                </a:solidFill>
+              </a:defRPr>
+            </a:pPr>
+            <a:r>
+              <a:t>• 一次付清代辦費（建議分期，信用卡付款可追回）</a:t>
+            </a:r>
+          </a:p>
+          <a:p>
+            <a:pPr>
+              <a:spcBef>
+                <a:spcPts val="1200"/>
+              </a:spcBef>
+              <a:defRPr sz="1800">
+                <a:solidFill>
+                  <a:srgbClr val="2C3E50"/>
+                </a:solidFill>
+              </a:defRPr>
+            </a:pPr>
+            <a:r>
+              <a:t>• 沒買保險（國外醫療費天價）</a:t>
+            </a:r>
+          </a:p>
+          <a:p>
+            <a:pPr>
+              <a:spcBef>
+                <a:spcPts val="1200"/>
+              </a:spcBef>
+              <a:defRPr sz="1800">
+                <a:solidFill>
+                  <a:srgbClr val="2C3E50"/>
+                </a:solidFill>
+              </a:defRPr>
+            </a:pPr>
+            <a:r>
+              <a:t>• 護照「Republic of China」問題（建議遮China或強調Taiwan）</a:t>
+            </a:r>
+          </a:p>
+          <a:p>
+            <a:pPr>
+              <a:spcBef>
+                <a:spcPts val="1200"/>
+              </a:spcBef>
+              <a:defRPr sz="1800">
+                <a:solidFill>
+                  <a:srgbClr val="2C3E50"/>
+                </a:solidFill>
+              </a:defRPr>
+            </a:pPr>
+            <a:r>
+              <a:t>• 被當中國人收保證金（辦電信時）</a:t>
+            </a:r>
+          </a:p>
+          <a:p>
+            <a:pPr>
+              <a:spcBef>
+                <a:spcPts val="1200"/>
+              </a:spcBef>
+              <a:defRPr sz="1800">
+                <a:solidFill>
+                  <a:srgbClr val="2C3E50"/>
+                </a:solidFill>
+              </a:defRPr>
+            </a:pPr>
+          </a:p>
+          <a:p>
+            <a:pPr>
+              <a:spcBef>
+                <a:spcPts val="1200"/>
+              </a:spcBef>
+              <a:defRPr sz="1800">
+                <a:solidFill>
+                  <a:srgbClr val="2C3E50"/>
+                </a:solidFill>
+              </a:defRPr>
+            </a:pPr>
+            <a:r>
+              <a:t>【申訴管道】台灣1950 / 國外找駐外機構</a:t>
             </a:r>
           </a:p>
         </p:txBody>

</xml_diff>